<commit_message>
fix(ppt): corrige le modèle relationnel (10 tables réelles au lieu de 14) + retire ZIP intérieur
</commit_message>
<xml_diff>
--- a/SmartCampus-Presentation.pptx
+++ b/SmartCampus-Presentation.pptx
@@ -14315,7 +14315,7 @@
                 </a:solidFill>
                 <a:latin typeface="Calibri"/>
               </a:rPr>
-              <a:t>13 entités, héritage users → profils, cardinalités cohérentes</a:t>
+              <a:t>10 entités, héritage users → profils, cardinalités cohérentes</a:t>
             </a:r>
           </a:p>
         </p:txBody>
@@ -14445,7 +14445,7 @@
                 </a:solidFill>
                 <a:latin typeface="Calibri"/>
               </a:rPr>
-              <a:t>•  courses ⟷ enrollments ⟷ students (table de jointure)</a:t>
+              <a:t>•  courses ⟷ enrollments ⟷ students (UNIQUE étudiant+cours)</a:t>
             </a:r>
           </a:p>
           <a:p>
@@ -14461,7 +14461,7 @@
                 </a:solidFill>
                 <a:latin typeface="Calibri"/>
               </a:rPr>
-              <a:t>•  grades : (enrollment, assessment, value, locked)</a:t>
+              <a:t>•  grades : note typée (CC1/CC2/DS/Projet/Examen) + is_locked</a:t>
             </a:r>
           </a:p>
           <a:p>
@@ -14477,7 +14477,7 @@
                 </a:solidFill>
                 <a:latin typeface="Calibri"/>
               </a:rPr>
-              <a:t>•  schedule_slots : créneaux horaires liés à un cours + salle + prof</a:t>
+              <a:t>•  schedule_slots : créneau (jour, heure, salle) lié au cours</a:t>
             </a:r>
           </a:p>
           <a:p>
@@ -14493,7 +14493,7 @@
                 </a:solidFill>
                 <a:latin typeface="Calibri"/>
               </a:rPr>
-              <a:t>•  messages : référencent users (anti-duplication)</a:t>
+              <a:t>•  messages &amp; notifications : référencent directement users</a:t>
             </a:r>
           </a:p>
         </p:txBody>
@@ -14897,7 +14897,7 @@
                 </a:solidFill>
                 <a:latin typeface="Calibri"/>
               </a:rPr>
-              <a:t>(id, email, password_hash, role, full_name, created_at)</a:t>
+              <a:t>(id, role, email, password_hash, first_name, last_name, gender, phone, is_active, created_at)</a:t>
             </a:r>
           </a:p>
         </p:txBody>
@@ -15011,7 +15011,7 @@
                 </a:solidFill>
                 <a:latin typeface="Calibri"/>
               </a:rPr>
-              <a:t>(#user_id, student_number, level, programme_id, group_label, ...)</a:t>
+              <a:t>(#user_id, student_number, filiere, niveau, group_td, date_naissance, date_inscription)</a:t>
             </a:r>
           </a:p>
         </p:txBody>
@@ -15125,7 +15125,7 @@
                 </a:solidFill>
                 <a:latin typeface="Calibri"/>
               </a:rPr>
-              <a:t>(#user_id, office, title, biography, ...)</a:t>
+              <a:t>(#user_id, employee_number, department, grade, office, hire_date)</a:t>
             </a:r>
           </a:p>
         </p:txBody>
@@ -15204,7 +15204,7 @@
                 </a:solidFill>
                 <a:latin typeface="Calibri"/>
               </a:rPr>
-              <a:t>programmes</a:t>
+              <a:t>courses</a:t>
             </a:r>
           </a:p>
         </p:txBody>
@@ -15239,7 +15239,7 @@
                 </a:solidFill>
                 <a:latin typeface="Calibri"/>
               </a:rPr>
-              <a:t>(id, code, name, level)</a:t>
+              <a:t>(id, code, name, credits, semester, niveau, department, #teacher_id, capacity, is_archived)</a:t>
             </a:r>
           </a:p>
         </p:txBody>
@@ -15318,7 +15318,7 @@
                 </a:solidFill>
                 <a:latin typeface="Calibri"/>
               </a:rPr>
-              <a:t>courses</a:t>
+              <a:t>prerequisites</a:t>
             </a:r>
           </a:p>
         </p:txBody>
@@ -15353,7 +15353,7 @@
                 </a:solidFill>
                 <a:latin typeface="Calibri"/>
               </a:rPr>
-              <a:t>(id, code, name, ects, semester, capacity, #teacher_id, #programme_id)</a:t>
+              <a:t>(#course_id, #prerequisite_course_id)</a:t>
             </a:r>
           </a:p>
         </p:txBody>
@@ -15366,7 +15366,7 @@
         </p:nvSpPr>
         <p:spPr>
           <a:xfrm>
-            <a:off x="365760" y="5029200"/>
+            <a:off x="6172200" y="1600200"/>
             <a:ext cx="5669280" cy="640080"/>
           </a:xfrm>
           <a:prstGeom prst="rect">
@@ -15410,7 +15410,7 @@
         </p:nvSpPr>
         <p:spPr>
           <a:xfrm>
-            <a:off x="502920" y="5074920"/>
+            <a:off x="6309360" y="1645920"/>
             <a:ext cx="1828800" cy="274320"/>
           </a:xfrm>
           <a:prstGeom prst="rect">
@@ -15432,7 +15432,7 @@
                 </a:solidFill>
                 <a:latin typeface="Calibri"/>
               </a:rPr>
-              <a:t>prerequisites</a:t>
+              <a:t>enrollments</a:t>
             </a:r>
           </a:p>
         </p:txBody>
@@ -15445,7 +15445,7 @@
         </p:nvSpPr>
         <p:spPr>
           <a:xfrm>
-            <a:off x="502920" y="5321808"/>
+            <a:off x="6309360" y="1892808"/>
             <a:ext cx="5394960" cy="320040"/>
           </a:xfrm>
           <a:prstGeom prst="rect">
@@ -15467,7 +15467,7 @@
                 </a:solidFill>
                 <a:latin typeface="Calibri"/>
               </a:rPr>
-              <a:t>(#course_id, #prerequisite_course_id)</a:t>
+              <a:t>(id, #student_id, #course_id, enrolled_at, status)  ·  UNIQUE(student, course)</a:t>
             </a:r>
           </a:p>
         </p:txBody>
@@ -15480,7 +15480,7 @@
         </p:nvSpPr>
         <p:spPr>
           <a:xfrm>
-            <a:off x="365760" y="5715000"/>
+            <a:off x="6172200" y="2286000"/>
             <a:ext cx="5669280" cy="640080"/>
           </a:xfrm>
           <a:prstGeom prst="rect">
@@ -15524,7 +15524,7 @@
         </p:nvSpPr>
         <p:spPr>
           <a:xfrm>
-            <a:off x="502920" y="5760720"/>
+            <a:off x="6309360" y="2331720"/>
             <a:ext cx="1828800" cy="274320"/>
           </a:xfrm>
           <a:prstGeom prst="rect">
@@ -15546,7 +15546,7 @@
                 </a:solidFill>
                 <a:latin typeface="Calibri"/>
               </a:rPr>
-              <a:t>rooms</a:t>
+              <a:t>grades</a:t>
             </a:r>
           </a:p>
         </p:txBody>
@@ -15559,7 +15559,7 @@
         </p:nvSpPr>
         <p:spPr>
           <a:xfrm>
-            <a:off x="502920" y="6007608"/>
+            <a:off x="6309360" y="2578608"/>
             <a:ext cx="5394960" cy="320040"/>
           </a:xfrm>
           <a:prstGeom prst="rect">
@@ -15581,7 +15581,7 @@
                 </a:solidFill>
                 <a:latin typeface="Calibri"/>
               </a:rPr>
-              <a:t>(id, label, capacity, building)</a:t>
+              <a:t>(id, #student_id, #course_id, eval_type, value, coefficient, is_locked, #graded_by)</a:t>
             </a:r>
           </a:p>
         </p:txBody>
@@ -15594,7 +15594,7 @@
         </p:nvSpPr>
         <p:spPr>
           <a:xfrm>
-            <a:off x="6172200" y="1600200"/>
+            <a:off x="6172200" y="2971800"/>
             <a:ext cx="5669280" cy="640080"/>
           </a:xfrm>
           <a:prstGeom prst="rect">
@@ -15638,7 +15638,7 @@
         </p:nvSpPr>
         <p:spPr>
           <a:xfrm>
-            <a:off x="6309360" y="1645920"/>
+            <a:off x="6309360" y="3017520"/>
             <a:ext cx="1828800" cy="274320"/>
           </a:xfrm>
           <a:prstGeom prst="rect">
@@ -15660,7 +15660,7 @@
                 </a:solidFill>
                 <a:latin typeface="Calibri"/>
               </a:rPr>
-              <a:t>enrollments</a:t>
+              <a:t>schedule_slots</a:t>
             </a:r>
           </a:p>
         </p:txBody>
@@ -15673,7 +15673,7 @@
         </p:nvSpPr>
         <p:spPr>
           <a:xfrm>
-            <a:off x="6309360" y="1892808"/>
+            <a:off x="6309360" y="3264408"/>
             <a:ext cx="5394960" cy="320040"/>
           </a:xfrm>
           <a:prstGeom prst="rect">
@@ -15695,7 +15695,7 @@
                 </a:solidFill>
                 <a:latin typeface="Calibri"/>
               </a:rPr>
-              <a:t>(id, #student_id, #course_id, enrolled_at, status)</a:t>
+              <a:t>(id, #course_id, day_of_week, start_time, end_time, room, group_td)</a:t>
             </a:r>
           </a:p>
         </p:txBody>
@@ -15708,7 +15708,7 @@
         </p:nvSpPr>
         <p:spPr>
           <a:xfrm>
-            <a:off x="6172200" y="2286000"/>
+            <a:off x="6172200" y="3657600"/>
             <a:ext cx="5669280" cy="640080"/>
           </a:xfrm>
           <a:prstGeom prst="rect">
@@ -15752,7 +15752,7 @@
         </p:nvSpPr>
         <p:spPr>
           <a:xfrm>
-            <a:off x="6309360" y="2331720"/>
+            <a:off x="6309360" y="3703320"/>
             <a:ext cx="1828800" cy="274320"/>
           </a:xfrm>
           <a:prstGeom prst="rect">
@@ -15774,7 +15774,7 @@
                 </a:solidFill>
                 <a:latin typeface="Calibri"/>
               </a:rPr>
-              <a:t>assessments</a:t>
+              <a:t>messages</a:t>
             </a:r>
           </a:p>
         </p:txBody>
@@ -15787,7 +15787,7 @@
         </p:nvSpPr>
         <p:spPr>
           <a:xfrm>
-            <a:off x="6309360" y="2578608"/>
+            <a:off x="6309360" y="3950208"/>
             <a:ext cx="5394960" cy="320040"/>
           </a:xfrm>
           <a:prstGeom prst="rect">
@@ -15809,7 +15809,7 @@
                 </a:solidFill>
                 <a:latin typeface="Calibri"/>
               </a:rPr>
-              <a:t>(id, #course_id, label, type, weight, due_date)</a:t>
+              <a:t>(id, #sender_id, #recipient_id, subject, body, is_read, sent_at, read_at)</a:t>
             </a:r>
           </a:p>
         </p:txBody>
@@ -15822,7 +15822,7 @@
         </p:nvSpPr>
         <p:spPr>
           <a:xfrm>
-            <a:off x="6172200" y="2971800"/>
+            <a:off x="6172200" y="4343400"/>
             <a:ext cx="5669280" cy="640080"/>
           </a:xfrm>
           <a:prstGeom prst="rect">
@@ -15866,7 +15866,7 @@
         </p:nvSpPr>
         <p:spPr>
           <a:xfrm>
-            <a:off x="6309360" y="3017520"/>
+            <a:off x="6309360" y="4389120"/>
             <a:ext cx="1828800" cy="274320"/>
           </a:xfrm>
           <a:prstGeom prst="rect">
@@ -15888,7 +15888,7 @@
                 </a:solidFill>
                 <a:latin typeface="Calibri"/>
               </a:rPr>
-              <a:t>grades</a:t>
+              <a:t>notifications</a:t>
             </a:r>
           </a:p>
         </p:txBody>
@@ -15901,7 +15901,7 @@
         </p:nvSpPr>
         <p:spPr>
           <a:xfrm>
-            <a:off x="6309360" y="3264408"/>
+            <a:off x="6309360" y="4636008"/>
             <a:ext cx="5394960" cy="320040"/>
           </a:xfrm>
           <a:prstGeom prst="rect">
@@ -15923,7 +15923,7 @@
                 </a:solidFill>
                 <a:latin typeface="Calibri"/>
               </a:rPr>
-              <a:t>(id, #enrollment_id, #assessment_id, value, locked, locked_at)</a:t>
+              <a:t>(id, #user_id, type, title, content, link, is_read, created_at)</a:t>
             </a:r>
           </a:p>
         </p:txBody>
@@ -15936,8 +15936,8 @@
         </p:nvSpPr>
         <p:spPr>
           <a:xfrm>
-            <a:off x="6172200" y="3657600"/>
-            <a:ext cx="5669280" cy="640080"/>
+            <a:off x="0" y="6583680"/>
+            <a:ext cx="12191695" cy="274320"/>
           </a:xfrm>
           <a:prstGeom prst="rect">
             <a:avLst/>
@@ -15980,462 +15980,6 @@
         </p:nvSpPr>
         <p:spPr>
           <a:xfrm>
-            <a:off x="6309360" y="3703320"/>
-            <a:ext cx="1828800" cy="274320"/>
-          </a:xfrm>
-          <a:prstGeom prst="rect">
-            <a:avLst/>
-          </a:prstGeom>
-          <a:noFill/>
-        </p:spPr>
-        <p:txBody>
-          <a:bodyPr wrap="square" lIns="0" rIns="0" tIns="0" bIns="0" anchor="t">
-            <a:spAutoFit/>
-          </a:bodyPr>
-          <a:lstStyle/>
-          <a:p>
-            <a:pPr algn="l"/>
-            <a:r>
-              <a:rPr sz="1300" b="1">
-                <a:solidFill>
-                  <a:srgbClr val="0B2A4A"/>
-                </a:solidFill>
-                <a:latin typeface="Calibri"/>
-              </a:rPr>
-              <a:t>schedule_slots</a:t>
-            </a:r>
-          </a:p>
-        </p:txBody>
-      </p:sp>
-      <p:sp>
-        <p:nvSpPr>
-          <p:cNvPr id="38" name="TextBox 37"/>
-          <p:cNvSpPr txBox="1"/>
-          <p:nvPr/>
-        </p:nvSpPr>
-        <p:spPr>
-          <a:xfrm>
-            <a:off x="6309360" y="3950208"/>
-            <a:ext cx="5394960" cy="320040"/>
-          </a:xfrm>
-          <a:prstGeom prst="rect">
-            <a:avLst/>
-          </a:prstGeom>
-          <a:noFill/>
-        </p:spPr>
-        <p:txBody>
-          <a:bodyPr wrap="square" lIns="0" rIns="0" tIns="0" bIns="0" anchor="t">
-            <a:spAutoFit/>
-          </a:bodyPr>
-          <a:lstStyle/>
-          <a:p>
-            <a:pPr algn="l"/>
-            <a:r>
-              <a:rPr sz="1100" b="0">
-                <a:solidFill>
-                  <a:srgbClr val="1B2631"/>
-                </a:solidFill>
-                <a:latin typeface="Calibri"/>
-              </a:rPr>
-              <a:t>(id, #course_id, #room_id, weekday, start_time, end_time)</a:t>
-            </a:r>
-          </a:p>
-        </p:txBody>
-      </p:sp>
-      <p:sp>
-        <p:nvSpPr>
-          <p:cNvPr id="39" name="Rectangle 38"/>
-          <p:cNvSpPr/>
-          <p:nvPr/>
-        </p:nvSpPr>
-        <p:spPr>
-          <a:xfrm>
-            <a:off x="6172200" y="4343400"/>
-            <a:ext cx="5669280" cy="640080"/>
-          </a:xfrm>
-          <a:prstGeom prst="rect">
-            <a:avLst/>
-          </a:prstGeom>
-          <a:solidFill>
-            <a:srgbClr val="F4F7FB"/>
-          </a:solidFill>
-          <a:ln>
-            <a:noFill/>
-          </a:ln>
-          <a:effectLst/>
-        </p:spPr>
-        <p:style>
-          <a:lnRef idx="1">
-            <a:schemeClr val="accent1"/>
-          </a:lnRef>
-          <a:fillRef idx="3">
-            <a:schemeClr val="accent1"/>
-          </a:fillRef>
-          <a:effectRef idx="2">
-            <a:schemeClr val="accent1"/>
-          </a:effectRef>
-          <a:fontRef idx="minor">
-            <a:schemeClr val="lt1"/>
-          </a:fontRef>
-        </p:style>
-        <p:txBody>
-          <a:bodyPr rtlCol="0" anchor="ctr"/>
-          <a:lstStyle/>
-          <a:p>
-            <a:pPr algn="ctr"/>
-          </a:p>
-        </p:txBody>
-      </p:sp>
-      <p:sp>
-        <p:nvSpPr>
-          <p:cNvPr id="40" name="TextBox 39"/>
-          <p:cNvSpPr txBox="1"/>
-          <p:nvPr/>
-        </p:nvSpPr>
-        <p:spPr>
-          <a:xfrm>
-            <a:off x="6309360" y="4389120"/>
-            <a:ext cx="1828800" cy="274320"/>
-          </a:xfrm>
-          <a:prstGeom prst="rect">
-            <a:avLst/>
-          </a:prstGeom>
-          <a:noFill/>
-        </p:spPr>
-        <p:txBody>
-          <a:bodyPr wrap="square" lIns="0" rIns="0" tIns="0" bIns="0" anchor="t">
-            <a:spAutoFit/>
-          </a:bodyPr>
-          <a:lstStyle/>
-          <a:p>
-            <a:pPr algn="l"/>
-            <a:r>
-              <a:rPr sz="1300" b="1">
-                <a:solidFill>
-                  <a:srgbClr val="0B2A4A"/>
-                </a:solidFill>
-                <a:latin typeface="Calibri"/>
-              </a:rPr>
-              <a:t>messages</a:t>
-            </a:r>
-          </a:p>
-        </p:txBody>
-      </p:sp>
-      <p:sp>
-        <p:nvSpPr>
-          <p:cNvPr id="41" name="TextBox 40"/>
-          <p:cNvSpPr txBox="1"/>
-          <p:nvPr/>
-        </p:nvSpPr>
-        <p:spPr>
-          <a:xfrm>
-            <a:off x="6309360" y="4636008"/>
-            <a:ext cx="5394960" cy="320040"/>
-          </a:xfrm>
-          <a:prstGeom prst="rect">
-            <a:avLst/>
-          </a:prstGeom>
-          <a:noFill/>
-        </p:spPr>
-        <p:txBody>
-          <a:bodyPr wrap="square" lIns="0" rIns="0" tIns="0" bIns="0" anchor="t">
-            <a:spAutoFit/>
-          </a:bodyPr>
-          <a:lstStyle/>
-          <a:p>
-            <a:pPr algn="l"/>
-            <a:r>
-              <a:rPr sz="1100" b="0">
-                <a:solidFill>
-                  <a:srgbClr val="1B2631"/>
-                </a:solidFill>
-                <a:latin typeface="Calibri"/>
-              </a:rPr>
-              <a:t>(id, #sender_id, #recipient_id, subject, body, sent_at, read_at)</a:t>
-            </a:r>
-          </a:p>
-        </p:txBody>
-      </p:sp>
-      <p:sp>
-        <p:nvSpPr>
-          <p:cNvPr id="42" name="Rectangle 41"/>
-          <p:cNvSpPr/>
-          <p:nvPr/>
-        </p:nvSpPr>
-        <p:spPr>
-          <a:xfrm>
-            <a:off x="6172200" y="5029200"/>
-            <a:ext cx="5669280" cy="640080"/>
-          </a:xfrm>
-          <a:prstGeom prst="rect">
-            <a:avLst/>
-          </a:prstGeom>
-          <a:solidFill>
-            <a:srgbClr val="F4F7FB"/>
-          </a:solidFill>
-          <a:ln>
-            <a:noFill/>
-          </a:ln>
-          <a:effectLst/>
-        </p:spPr>
-        <p:style>
-          <a:lnRef idx="1">
-            <a:schemeClr val="accent1"/>
-          </a:lnRef>
-          <a:fillRef idx="3">
-            <a:schemeClr val="accent1"/>
-          </a:fillRef>
-          <a:effectRef idx="2">
-            <a:schemeClr val="accent1"/>
-          </a:effectRef>
-          <a:fontRef idx="minor">
-            <a:schemeClr val="lt1"/>
-          </a:fontRef>
-        </p:style>
-        <p:txBody>
-          <a:bodyPr rtlCol="0" anchor="ctr"/>
-          <a:lstStyle/>
-          <a:p>
-            <a:pPr algn="ctr"/>
-          </a:p>
-        </p:txBody>
-      </p:sp>
-      <p:sp>
-        <p:nvSpPr>
-          <p:cNvPr id="43" name="TextBox 42"/>
-          <p:cNvSpPr txBox="1"/>
-          <p:nvPr/>
-        </p:nvSpPr>
-        <p:spPr>
-          <a:xfrm>
-            <a:off x="6309360" y="5074920"/>
-            <a:ext cx="1828800" cy="274320"/>
-          </a:xfrm>
-          <a:prstGeom prst="rect">
-            <a:avLst/>
-          </a:prstGeom>
-          <a:noFill/>
-        </p:spPr>
-        <p:txBody>
-          <a:bodyPr wrap="square" lIns="0" rIns="0" tIns="0" bIns="0" anchor="t">
-            <a:spAutoFit/>
-          </a:bodyPr>
-          <a:lstStyle/>
-          <a:p>
-            <a:pPr algn="l"/>
-            <a:r>
-              <a:rPr sz="1300" b="1">
-                <a:solidFill>
-                  <a:srgbClr val="0B2A4A"/>
-                </a:solidFill>
-                <a:latin typeface="Calibri"/>
-              </a:rPr>
-              <a:t>notifications</a:t>
-            </a:r>
-          </a:p>
-        </p:txBody>
-      </p:sp>
-      <p:sp>
-        <p:nvSpPr>
-          <p:cNvPr id="44" name="TextBox 43"/>
-          <p:cNvSpPr txBox="1"/>
-          <p:nvPr/>
-        </p:nvSpPr>
-        <p:spPr>
-          <a:xfrm>
-            <a:off x="6309360" y="5321808"/>
-            <a:ext cx="5394960" cy="320040"/>
-          </a:xfrm>
-          <a:prstGeom prst="rect">
-            <a:avLst/>
-          </a:prstGeom>
-          <a:noFill/>
-        </p:spPr>
-        <p:txBody>
-          <a:bodyPr wrap="square" lIns="0" rIns="0" tIns="0" bIns="0" anchor="t">
-            <a:spAutoFit/>
-          </a:bodyPr>
-          <a:lstStyle/>
-          <a:p>
-            <a:pPr algn="l"/>
-            <a:r>
-              <a:rPr sz="1100" b="0">
-                <a:solidFill>
-                  <a:srgbClr val="1B2631"/>
-                </a:solidFill>
-                <a:latin typeface="Calibri"/>
-              </a:rPr>
-              <a:t>(id, #user_id, type, payload, created_at, read_at)</a:t>
-            </a:r>
-          </a:p>
-        </p:txBody>
-      </p:sp>
-      <p:sp>
-        <p:nvSpPr>
-          <p:cNvPr id="45" name="Rectangle 44"/>
-          <p:cNvSpPr/>
-          <p:nvPr/>
-        </p:nvSpPr>
-        <p:spPr>
-          <a:xfrm>
-            <a:off x="6172200" y="5715000"/>
-            <a:ext cx="5669280" cy="640080"/>
-          </a:xfrm>
-          <a:prstGeom prst="rect">
-            <a:avLst/>
-          </a:prstGeom>
-          <a:solidFill>
-            <a:srgbClr val="F4F7FB"/>
-          </a:solidFill>
-          <a:ln>
-            <a:noFill/>
-          </a:ln>
-          <a:effectLst/>
-        </p:spPr>
-        <p:style>
-          <a:lnRef idx="1">
-            <a:schemeClr val="accent1"/>
-          </a:lnRef>
-          <a:fillRef idx="3">
-            <a:schemeClr val="accent1"/>
-          </a:fillRef>
-          <a:effectRef idx="2">
-            <a:schemeClr val="accent1"/>
-          </a:effectRef>
-          <a:fontRef idx="minor">
-            <a:schemeClr val="lt1"/>
-          </a:fontRef>
-        </p:style>
-        <p:txBody>
-          <a:bodyPr rtlCol="0" anchor="ctr"/>
-          <a:lstStyle/>
-          <a:p>
-            <a:pPr algn="ctr"/>
-          </a:p>
-        </p:txBody>
-      </p:sp>
-      <p:sp>
-        <p:nvSpPr>
-          <p:cNvPr id="46" name="TextBox 45"/>
-          <p:cNvSpPr txBox="1"/>
-          <p:nvPr/>
-        </p:nvSpPr>
-        <p:spPr>
-          <a:xfrm>
-            <a:off x="6309360" y="5760720"/>
-            <a:ext cx="1828800" cy="274320"/>
-          </a:xfrm>
-          <a:prstGeom prst="rect">
-            <a:avLst/>
-          </a:prstGeom>
-          <a:noFill/>
-        </p:spPr>
-        <p:txBody>
-          <a:bodyPr wrap="square" lIns="0" rIns="0" tIns="0" bIns="0" anchor="t">
-            <a:spAutoFit/>
-          </a:bodyPr>
-          <a:lstStyle/>
-          <a:p>
-            <a:pPr algn="l"/>
-            <a:r>
-              <a:rPr sz="1300" b="1">
-                <a:solidFill>
-                  <a:srgbClr val="0B2A4A"/>
-                </a:solidFill>
-                <a:latin typeface="Calibri"/>
-              </a:rPr>
-              <a:t>audit_logs</a:t>
-            </a:r>
-          </a:p>
-        </p:txBody>
-      </p:sp>
-      <p:sp>
-        <p:nvSpPr>
-          <p:cNvPr id="47" name="TextBox 46"/>
-          <p:cNvSpPr txBox="1"/>
-          <p:nvPr/>
-        </p:nvSpPr>
-        <p:spPr>
-          <a:xfrm>
-            <a:off x="6309360" y="6007608"/>
-            <a:ext cx="5394960" cy="320040"/>
-          </a:xfrm>
-          <a:prstGeom prst="rect">
-            <a:avLst/>
-          </a:prstGeom>
-          <a:noFill/>
-        </p:spPr>
-        <p:txBody>
-          <a:bodyPr wrap="square" lIns="0" rIns="0" tIns="0" bIns="0" anchor="t">
-            <a:spAutoFit/>
-          </a:bodyPr>
-          <a:lstStyle/>
-          <a:p>
-            <a:pPr algn="l"/>
-            <a:r>
-              <a:rPr sz="1100" b="0">
-                <a:solidFill>
-                  <a:srgbClr val="1B2631"/>
-                </a:solidFill>
-                <a:latin typeface="Calibri"/>
-              </a:rPr>
-              <a:t>(id, #user_id, action, target, created_at)</a:t>
-            </a:r>
-          </a:p>
-        </p:txBody>
-      </p:sp>
-      <p:sp>
-        <p:nvSpPr>
-          <p:cNvPr id="48" name="Rectangle 47"/>
-          <p:cNvSpPr/>
-          <p:nvPr/>
-        </p:nvSpPr>
-        <p:spPr>
-          <a:xfrm>
-            <a:off x="0" y="6583680"/>
-            <a:ext cx="12191695" cy="274320"/>
-          </a:xfrm>
-          <a:prstGeom prst="rect">
-            <a:avLst/>
-          </a:prstGeom>
-          <a:solidFill>
-            <a:srgbClr val="F4F7FB"/>
-          </a:solidFill>
-          <a:ln>
-            <a:noFill/>
-          </a:ln>
-          <a:effectLst/>
-        </p:spPr>
-        <p:style>
-          <a:lnRef idx="1">
-            <a:schemeClr val="accent1"/>
-          </a:lnRef>
-          <a:fillRef idx="3">
-            <a:schemeClr val="accent1"/>
-          </a:fillRef>
-          <a:effectRef idx="2">
-            <a:schemeClr val="accent1"/>
-          </a:effectRef>
-          <a:fontRef idx="minor">
-            <a:schemeClr val="lt1"/>
-          </a:fontRef>
-        </p:style>
-        <p:txBody>
-          <a:bodyPr rtlCol="0" anchor="ctr"/>
-          <a:lstStyle/>
-          <a:p>
-            <a:pPr algn="ctr"/>
-          </a:p>
-        </p:txBody>
-      </p:sp>
-      <p:sp>
-        <p:nvSpPr>
-          <p:cNvPr id="49" name="TextBox 48"/>
-          <p:cNvSpPr txBox="1"/>
-          <p:nvPr/>
-        </p:nvSpPr>
-        <p:spPr>
-          <a:xfrm>
             <a:off x="365760" y="6601968"/>
             <a:ext cx="7315200" cy="274320"/>
           </a:xfrm>
@@ -16465,7 +16009,7 @@
       </p:sp>
       <p:sp>
         <p:nvSpPr>
-          <p:cNvPr id="50" name="TextBox 49"/>
+          <p:cNvPr id="38" name="TextBox 37"/>
           <p:cNvSpPr txBox="1"/>
           <p:nvPr/>
         </p:nvSpPr>

</xml_diff>